<commit_message>
content update for ais and exams
</commit_message>
<xml_diff>
--- a/static/pages/course_dv/dv47-poster/example-poster-48x36.pptx
+++ b/static/pages/course_dv/dv47-poster/example-poster-48x36.pptx
@@ -4,10 +4,13 @@
   <p:sldMasterIdLst>
     <p:sldMasterId id="2147483648" r:id="rId1"/>
   </p:sldMasterIdLst>
+  <p:notesMasterIdLst>
+    <p:notesMasterId r:id="rId3"/>
+  </p:notesMasterIdLst>
   <p:sldIdLst>
-    <p:sldId id="256" r:id="rId7"/>
+    <p:sldId id="256" r:id="rId2"/>
   </p:sldIdLst>
-  <p:sldSz cx="43891200" cy="32918400" type="screen4x3"/>
+  <p:sldSz cx="43891200" cy="32918400"/>
   <p:notesSz cx="6858000" cy="9144000"/>
   <p:defaultTextStyle>
     <a:defPPr>
@@ -104,18 +107,39 @@
       </a:defRPr>
     </a:lvl9pPr>
   </p:defaultTextStyle>
+  <p:extLst>
+    <p:ext uri="{EFAFB233-063F-42B5-8137-9DF3F51BA10A}">
+      <p15:sldGuideLst xmlns:p15="http://schemas.microsoft.com/office/powerpoint/2012/main">
+        <p15:guide id="1" orient="horz" pos="2160">
+          <p15:clr>
+            <a:srgbClr val="A4A3A4"/>
+          </p15:clr>
+        </p15:guide>
+        <p15:guide id="2" pos="2880">
+          <p15:clr>
+            <a:srgbClr val="A4A3A4"/>
+          </p15:clr>
+        </p15:guide>
+      </p15:sldGuideLst>
+    </p:ext>
+  </p:extLst>
 </p:presentation>
 </file>
 
 <file path=ppt/charts/chart1.xml><?xml version="1.0" encoding="utf-8"?>
-<c:chartSpace xmlns:c="http://schemas.openxmlformats.org/drawingml/2006/chart" xmlns:a="http://schemas.openxmlformats.org/drawingml/2006/main" xmlns:r="http://schemas.openxmlformats.org/officeDocument/2006/relationships">
+<c:chartSpace xmlns:c="http://schemas.openxmlformats.org/drawingml/2006/chart" xmlns:a="http://schemas.openxmlformats.org/drawingml/2006/main" xmlns:r="http://schemas.openxmlformats.org/officeDocument/2006/relationships" xmlns:c16r2="http://schemas.microsoft.com/office/drawing/2015/06/chart">
   <c:date1904 val="0"/>
+  <c:lang val="en-US"/>
+  <c:roundedCorners val="1"/>
+  <c:style val="2"/>
   <c:chart>
     <c:autoTitleDeleted val="1"/>
     <c:plotArea>
+      <c:layout/>
       <c:barChart>
         <c:barDir val="bar"/>
         <c:grouping val="clustered"/>
+        <c:varyColors val="1"/>
         <c:ser>
           <c:idx val="0"/>
           <c:order val="0"/>
@@ -130,8 +154,11 @@
               </c:strCache>
             </c:strRef>
           </c:tx>
+          <c:invertIfNegative val="1"/>
           <c:dPt>
             <c:idx val="0"/>
+            <c:invertIfNegative val="1"/>
+            <c:bubble3D val="0"/>
             <c:spPr>
               <a:solidFill>
                 <a:srgbClr val="BBBBBB"/>
@@ -140,9 +167,16 @@
                 <a:noFill/>
               </a:ln>
             </c:spPr>
+            <c:extLst>
+              <c:ext xmlns:c16="http://schemas.microsoft.com/office/drawing/2014/chart" uri="{C3380CC4-5D6E-409C-BE32-E72D297353CC}">
+                <c16:uniqueId val="{00000001-C1F8-CF44-B0C0-4523C6256ABF}"/>
+              </c:ext>
+            </c:extLst>
           </c:dPt>
           <c:dPt>
             <c:idx val="1"/>
+            <c:invertIfNegative val="1"/>
+            <c:bubble3D val="0"/>
             <c:spPr>
               <a:solidFill>
                 <a:srgbClr val="0F5FA6"/>
@@ -151,9 +185,16 @@
                 <a:noFill/>
               </a:ln>
             </c:spPr>
+            <c:extLst>
+              <c:ext xmlns:c16="http://schemas.microsoft.com/office/drawing/2014/chart" uri="{C3380CC4-5D6E-409C-BE32-E72D297353CC}">
+                <c16:uniqueId val="{00000003-C1F8-CF44-B0C0-4523C6256ABF}"/>
+              </c:ext>
+            </c:extLst>
           </c:dPt>
           <c:dPt>
             <c:idx val="2"/>
+            <c:invertIfNegative val="1"/>
+            <c:bubble3D val="0"/>
             <c:spPr>
               <a:solidFill>
                 <a:srgbClr val="BBBBBB"/>
@@ -162,9 +203,16 @@
                 <a:noFill/>
               </a:ln>
             </c:spPr>
+            <c:extLst>
+              <c:ext xmlns:c16="http://schemas.microsoft.com/office/drawing/2014/chart" uri="{C3380CC4-5D6E-409C-BE32-E72D297353CC}">
+                <c16:uniqueId val="{00000005-C1F8-CF44-B0C0-4523C6256ABF}"/>
+              </c:ext>
+            </c:extLst>
           </c:dPt>
           <c:dPt>
             <c:idx val="3"/>
+            <c:invertIfNegative val="1"/>
+            <c:bubble3D val="0"/>
             <c:spPr>
               <a:solidFill>
                 <a:srgbClr val="BBBBBB"/>
@@ -173,7 +221,15 @@
                 <a:noFill/>
               </a:ln>
             </c:spPr>
+            <c:extLst>
+              <c:ext xmlns:c16="http://schemas.microsoft.com/office/drawing/2014/chart" uri="{C3380CC4-5D6E-409C-BE32-E72D297353CC}">
+                <c16:uniqueId val="{00000007-C1F8-CF44-B0C0-4523C6256ABF}"/>
+              </c:ext>
+            </c:extLst>
           </c:dPt>
+          <c:dLbls>
+            <c:delete val="1"/>
+          </c:dLbls>
           <c:cat>
             <c:strRef>
               <c:f>Sheet1!$A$2:$A$5</c:f>
@@ -216,23 +272,13 @@
               </c:numCache>
             </c:numRef>
           </c:val>
+          <c:extLst>
+            <c:ext xmlns:c16="http://schemas.microsoft.com/office/drawing/2014/chart" uri="{C3380CC4-5D6E-409C-BE32-E72D297353CC}">
+              <c16:uniqueId val="{00000008-C1F8-CF44-B0C0-4523C6256ABF}"/>
+            </c:ext>
+          </c:extLst>
         </c:ser>
         <c:dLbls>
-          <c:numFmt formatCode="&quot;$&quot;#,##0.00" sourceLinked="0"/>
-          <c:txPr>
-            <a:bodyPr/>
-            <a:lstStyle/>
-            <a:p>
-              <a:pPr>
-                <a:defRPr sz="2600" b="1">
-                  <a:solidFill>
-                    <a:srgbClr val="222222"/>
-                  </a:solidFill>
-                  <a:latin typeface="Calibri"/>
-                </a:defRPr>
-              </a:pPr>
-            </a:p>
-          </c:txPr>
           <c:dLblPos val="outEnd"/>
           <c:showLegendKey val="0"/>
           <c:showVal val="1"/>
@@ -240,7 +286,6 @@
           <c:showSerName val="0"/>
           <c:showPercent val="0"/>
           <c:showBubbleSize val="0"/>
-          <c:showLeaderLines val="1"/>
         </c:dLbls>
         <c:gapWidth val="60"/>
         <c:axId val="-2068027336"/>
@@ -253,6 +298,7 @@
         </c:scaling>
         <c:delete val="0"/>
         <c:axPos val="l"/>
+        <c:numFmt formatCode="General" sourceLinked="0"/>
         <c:majorTickMark val="out"/>
         <c:minorTickMark val="none"/>
         <c:tickLblPos val="nextTo"/>
@@ -268,13 +314,14 @@
           <a:lstStyle/>
           <a:p>
             <a:pPr>
-              <a:defRPr sz="2600">
+              <a:defRPr sz="4000">
                 <a:solidFill>
                   <a:srgbClr val="222222"/>
                 </a:solidFill>
                 <a:latin typeface="Calibri"/>
               </a:defRPr>
             </a:pPr>
+            <a:endParaRPr lang="en-US"/>
           </a:p>
         </c:txPr>
         <c:crossAx val="-2113994440"/>
@@ -286,7 +333,9 @@
       </c:catAx>
       <c:valAx>
         <c:axId val="-2113994440"/>
-        <c:scaling/>
+        <c:scaling>
+          <c:orientation val="minMax"/>
+        </c:scaling>
         <c:delete val="0"/>
         <c:axPos val="b"/>
         <c:majorGridlines>
@@ -312,20 +361,24 @@
           <a:lstStyle/>
           <a:p>
             <a:pPr>
-              <a:defRPr sz="2200">
+              <a:defRPr sz="4400">
                 <a:solidFill>
                   <a:srgbClr val="666666"/>
                 </a:solidFill>
                 <a:latin typeface="Calibri"/>
               </a:defRPr>
             </a:pPr>
+            <a:endParaRPr lang="en-US"/>
           </a:p>
         </c:txPr>
         <c:crossAx val="-2068027336"/>
         <c:crosses val="autoZero"/>
+        <c:crossBetween val="between"/>
       </c:valAx>
     </c:plotArea>
+    <c:plotVisOnly val="1"/>
     <c:dispBlanksAs val="gap"/>
+    <c:showDLblsOverMax val="1"/>
   </c:chart>
   <c:txPr>
     <a:bodyPr/>
@@ -345,6 +398,439 @@
 </c:chartSpace>
 </file>
 
+<file path=ppt/notesMasters/notesMaster1.xml><?xml version="1.0" encoding="utf-8"?>
+<p:notesMaster xmlns:a="http://schemas.openxmlformats.org/drawingml/2006/main" xmlns:r="http://schemas.openxmlformats.org/officeDocument/2006/relationships" xmlns:p="http://schemas.openxmlformats.org/presentationml/2006/main">
+  <p:cSld>
+    <p:bg>
+      <p:bgRef idx="1001">
+        <a:schemeClr val="bg1"/>
+      </p:bgRef>
+    </p:bg>
+    <p:spTree>
+      <p:nvGrpSpPr>
+        <p:cNvPr id="1" name=""/>
+        <p:cNvGrpSpPr/>
+        <p:nvPr/>
+      </p:nvGrpSpPr>
+      <p:grpSpPr>
+        <a:xfrm>
+          <a:off x="0" y="0"/>
+          <a:ext cx="0" cy="0"/>
+          <a:chOff x="0" y="0"/>
+          <a:chExt cx="0" cy="0"/>
+        </a:xfrm>
+      </p:grpSpPr>
+      <p:sp>
+        <p:nvSpPr>
+          <p:cNvPr id="2" name="Header Placeholder 1"/>
+          <p:cNvSpPr>
+            <a:spLocks noGrp="1"/>
+          </p:cNvSpPr>
+          <p:nvPr>
+            <p:ph type="hdr" sz="quarter"/>
+          </p:nvPr>
+        </p:nvSpPr>
+        <p:spPr>
+          <a:xfrm>
+            <a:off x="0" y="0"/>
+            <a:ext cx="2971800" cy="458788"/>
+          </a:xfrm>
+          <a:prstGeom prst="rect">
+            <a:avLst/>
+          </a:prstGeom>
+        </p:spPr>
+        <p:txBody>
+          <a:bodyPr vert="horz" lIns="91440" tIns="45720" rIns="91440" bIns="45720" rtlCol="0"/>
+          <a:lstStyle>
+            <a:lvl1pPr algn="l">
+              <a:defRPr sz="1200"/>
+            </a:lvl1pPr>
+          </a:lstStyle>
+          <a:p>
+            <a:endParaRPr lang="en-US"/>
+          </a:p>
+        </p:txBody>
+      </p:sp>
+      <p:sp>
+        <p:nvSpPr>
+          <p:cNvPr id="3" name="Date Placeholder 2"/>
+          <p:cNvSpPr>
+            <a:spLocks noGrp="1"/>
+          </p:cNvSpPr>
+          <p:nvPr>
+            <p:ph type="dt" idx="1"/>
+          </p:nvPr>
+        </p:nvSpPr>
+        <p:spPr>
+          <a:xfrm>
+            <a:off x="3884613" y="0"/>
+            <a:ext cx="2971800" cy="458788"/>
+          </a:xfrm>
+          <a:prstGeom prst="rect">
+            <a:avLst/>
+          </a:prstGeom>
+        </p:spPr>
+        <p:txBody>
+          <a:bodyPr vert="horz" lIns="91440" tIns="45720" rIns="91440" bIns="45720" rtlCol="0"/>
+          <a:lstStyle>
+            <a:lvl1pPr algn="r">
+              <a:defRPr sz="1200"/>
+            </a:lvl1pPr>
+          </a:lstStyle>
+          <a:p>
+            <a:fld id="{B3173A0F-D950-784E-9296-00E69C377436}" type="datetimeFigureOut">
+              <a:rPr lang="en-US" smtClean="0"/>
+              <a:t>10/12/26</a:t>
+            </a:fld>
+            <a:endParaRPr lang="en-US"/>
+          </a:p>
+        </p:txBody>
+      </p:sp>
+      <p:sp>
+        <p:nvSpPr>
+          <p:cNvPr id="4" name="Slide Image Placeholder 3"/>
+          <p:cNvSpPr>
+            <a:spLocks noGrp="1" noRot="1" noChangeAspect="1"/>
+          </p:cNvSpPr>
+          <p:nvPr>
+            <p:ph type="sldImg" idx="2"/>
+          </p:nvPr>
+        </p:nvSpPr>
+        <p:spPr>
+          <a:xfrm>
+            <a:off x="1371600" y="1143000"/>
+            <a:ext cx="4114800" cy="3086100"/>
+          </a:xfrm>
+          <a:prstGeom prst="rect">
+            <a:avLst/>
+          </a:prstGeom>
+          <a:noFill/>
+          <a:ln w="12700">
+            <a:solidFill>
+              <a:prstClr val="black"/>
+            </a:solidFill>
+          </a:ln>
+        </p:spPr>
+        <p:txBody>
+          <a:bodyPr vert="horz" lIns="91440" tIns="45720" rIns="91440" bIns="45720" rtlCol="0" anchor="ctr"/>
+          <a:lstStyle/>
+          <a:p>
+            <a:endParaRPr lang="en-US"/>
+          </a:p>
+        </p:txBody>
+      </p:sp>
+      <p:sp>
+        <p:nvSpPr>
+          <p:cNvPr id="5" name="Notes Placeholder 4"/>
+          <p:cNvSpPr>
+            <a:spLocks noGrp="1"/>
+          </p:cNvSpPr>
+          <p:nvPr>
+            <p:ph type="body" sz="quarter" idx="3"/>
+          </p:nvPr>
+        </p:nvSpPr>
+        <p:spPr>
+          <a:xfrm>
+            <a:off x="685800" y="4400550"/>
+            <a:ext cx="5486400" cy="3600450"/>
+          </a:xfrm>
+          <a:prstGeom prst="rect">
+            <a:avLst/>
+          </a:prstGeom>
+        </p:spPr>
+        <p:txBody>
+          <a:bodyPr vert="horz" lIns="91440" tIns="45720" rIns="91440" bIns="45720" rtlCol="0"/>
+          <a:lstStyle/>
+          <a:p>
+            <a:pPr lvl="0"/>
+            <a:r>
+              <a:rPr lang="en-US"/>
+              <a:t>Click to edit Master text styles</a:t>
+            </a:r>
+          </a:p>
+          <a:p>
+            <a:pPr lvl="1"/>
+            <a:r>
+              <a:rPr lang="en-US"/>
+              <a:t>Second level</a:t>
+            </a:r>
+          </a:p>
+          <a:p>
+            <a:pPr lvl="2"/>
+            <a:r>
+              <a:rPr lang="en-US"/>
+              <a:t>Third level</a:t>
+            </a:r>
+          </a:p>
+          <a:p>
+            <a:pPr lvl="3"/>
+            <a:r>
+              <a:rPr lang="en-US"/>
+              <a:t>Fourth level</a:t>
+            </a:r>
+          </a:p>
+          <a:p>
+            <a:pPr lvl="4"/>
+            <a:r>
+              <a:rPr lang="en-US"/>
+              <a:t>Fifth level</a:t>
+            </a:r>
+          </a:p>
+        </p:txBody>
+      </p:sp>
+      <p:sp>
+        <p:nvSpPr>
+          <p:cNvPr id="6" name="Footer Placeholder 5"/>
+          <p:cNvSpPr>
+            <a:spLocks noGrp="1"/>
+          </p:cNvSpPr>
+          <p:nvPr>
+            <p:ph type="ftr" sz="quarter" idx="4"/>
+          </p:nvPr>
+        </p:nvSpPr>
+        <p:spPr>
+          <a:xfrm>
+            <a:off x="0" y="8685213"/>
+            <a:ext cx="2971800" cy="458787"/>
+          </a:xfrm>
+          <a:prstGeom prst="rect">
+            <a:avLst/>
+          </a:prstGeom>
+        </p:spPr>
+        <p:txBody>
+          <a:bodyPr vert="horz" lIns="91440" tIns="45720" rIns="91440" bIns="45720" rtlCol="0" anchor="b"/>
+          <a:lstStyle>
+            <a:lvl1pPr algn="l">
+              <a:defRPr sz="1200"/>
+            </a:lvl1pPr>
+          </a:lstStyle>
+          <a:p>
+            <a:endParaRPr lang="en-US"/>
+          </a:p>
+        </p:txBody>
+      </p:sp>
+      <p:sp>
+        <p:nvSpPr>
+          <p:cNvPr id="7" name="Slide Number Placeholder 6"/>
+          <p:cNvSpPr>
+            <a:spLocks noGrp="1"/>
+          </p:cNvSpPr>
+          <p:nvPr>
+            <p:ph type="sldNum" sz="quarter" idx="5"/>
+          </p:nvPr>
+        </p:nvSpPr>
+        <p:spPr>
+          <a:xfrm>
+            <a:off x="3884613" y="8685213"/>
+            <a:ext cx="2971800" cy="458787"/>
+          </a:xfrm>
+          <a:prstGeom prst="rect">
+            <a:avLst/>
+          </a:prstGeom>
+        </p:spPr>
+        <p:txBody>
+          <a:bodyPr vert="horz" lIns="91440" tIns="45720" rIns="91440" bIns="45720" rtlCol="0" anchor="b"/>
+          <a:lstStyle>
+            <a:lvl1pPr algn="r">
+              <a:defRPr sz="1200"/>
+            </a:lvl1pPr>
+          </a:lstStyle>
+          <a:p>
+            <a:fld id="{709456F3-6FBD-E749-9920-17BD4DF4BA60}" type="slidenum">
+              <a:rPr lang="en-US" smtClean="0"/>
+              <a:t>‹#›</a:t>
+            </a:fld>
+            <a:endParaRPr lang="en-US"/>
+          </a:p>
+        </p:txBody>
+      </p:sp>
+    </p:spTree>
+    <p:extLst>
+      <p:ext uri="{BB962C8B-B14F-4D97-AF65-F5344CB8AC3E}">
+        <p14:creationId xmlns:p14="http://schemas.microsoft.com/office/powerpoint/2010/main" val="4005554791"/>
+      </p:ext>
+    </p:extLst>
+  </p:cSld>
+  <p:clrMap bg1="lt1" tx1="dk1" bg2="lt2" tx2="dk2" accent1="accent1" accent2="accent2" accent3="accent3" accent4="accent4" accent5="accent5" accent6="accent6" hlink="hlink" folHlink="folHlink"/>
+  <p:notesStyle>
+    <a:lvl1pPr marL="0" algn="l" defTabSz="914400" rtl="0" eaLnBrk="1" latinLnBrk="0" hangingPunct="1">
+      <a:defRPr sz="1200" kern="1200">
+        <a:solidFill>
+          <a:schemeClr val="tx1"/>
+        </a:solidFill>
+        <a:latin typeface="+mn-lt"/>
+        <a:ea typeface="+mn-ea"/>
+        <a:cs typeface="+mn-cs"/>
+      </a:defRPr>
+    </a:lvl1pPr>
+    <a:lvl2pPr marL="457200" algn="l" defTabSz="914400" rtl="0" eaLnBrk="1" latinLnBrk="0" hangingPunct="1">
+      <a:defRPr sz="1200" kern="1200">
+        <a:solidFill>
+          <a:schemeClr val="tx1"/>
+        </a:solidFill>
+        <a:latin typeface="+mn-lt"/>
+        <a:ea typeface="+mn-ea"/>
+        <a:cs typeface="+mn-cs"/>
+      </a:defRPr>
+    </a:lvl2pPr>
+    <a:lvl3pPr marL="914400" algn="l" defTabSz="914400" rtl="0" eaLnBrk="1" latinLnBrk="0" hangingPunct="1">
+      <a:defRPr sz="1200" kern="1200">
+        <a:solidFill>
+          <a:schemeClr val="tx1"/>
+        </a:solidFill>
+        <a:latin typeface="+mn-lt"/>
+        <a:ea typeface="+mn-ea"/>
+        <a:cs typeface="+mn-cs"/>
+      </a:defRPr>
+    </a:lvl3pPr>
+    <a:lvl4pPr marL="1371600" algn="l" defTabSz="914400" rtl="0" eaLnBrk="1" latinLnBrk="0" hangingPunct="1">
+      <a:defRPr sz="1200" kern="1200">
+        <a:solidFill>
+          <a:schemeClr val="tx1"/>
+        </a:solidFill>
+        <a:latin typeface="+mn-lt"/>
+        <a:ea typeface="+mn-ea"/>
+        <a:cs typeface="+mn-cs"/>
+      </a:defRPr>
+    </a:lvl4pPr>
+    <a:lvl5pPr marL="1828800" algn="l" defTabSz="914400" rtl="0" eaLnBrk="1" latinLnBrk="0" hangingPunct="1">
+      <a:defRPr sz="1200" kern="1200">
+        <a:solidFill>
+          <a:schemeClr val="tx1"/>
+        </a:solidFill>
+        <a:latin typeface="+mn-lt"/>
+        <a:ea typeface="+mn-ea"/>
+        <a:cs typeface="+mn-cs"/>
+      </a:defRPr>
+    </a:lvl5pPr>
+    <a:lvl6pPr marL="2286000" algn="l" defTabSz="914400" rtl="0" eaLnBrk="1" latinLnBrk="0" hangingPunct="1">
+      <a:defRPr sz="1200" kern="1200">
+        <a:solidFill>
+          <a:schemeClr val="tx1"/>
+        </a:solidFill>
+        <a:latin typeface="+mn-lt"/>
+        <a:ea typeface="+mn-ea"/>
+        <a:cs typeface="+mn-cs"/>
+      </a:defRPr>
+    </a:lvl6pPr>
+    <a:lvl7pPr marL="2743200" algn="l" defTabSz="914400" rtl="0" eaLnBrk="1" latinLnBrk="0" hangingPunct="1">
+      <a:defRPr sz="1200" kern="1200">
+        <a:solidFill>
+          <a:schemeClr val="tx1"/>
+        </a:solidFill>
+        <a:latin typeface="+mn-lt"/>
+        <a:ea typeface="+mn-ea"/>
+        <a:cs typeface="+mn-cs"/>
+      </a:defRPr>
+    </a:lvl7pPr>
+    <a:lvl8pPr marL="3200400" algn="l" defTabSz="914400" rtl="0" eaLnBrk="1" latinLnBrk="0" hangingPunct="1">
+      <a:defRPr sz="1200" kern="1200">
+        <a:solidFill>
+          <a:schemeClr val="tx1"/>
+        </a:solidFill>
+        <a:latin typeface="+mn-lt"/>
+        <a:ea typeface="+mn-ea"/>
+        <a:cs typeface="+mn-cs"/>
+      </a:defRPr>
+    </a:lvl8pPr>
+    <a:lvl9pPr marL="3657600" algn="l" defTabSz="914400" rtl="0" eaLnBrk="1" latinLnBrk="0" hangingPunct="1">
+      <a:defRPr sz="1200" kern="1200">
+        <a:solidFill>
+          <a:schemeClr val="tx1"/>
+        </a:solidFill>
+        <a:latin typeface="+mn-lt"/>
+        <a:ea typeface="+mn-ea"/>
+        <a:cs typeface="+mn-cs"/>
+      </a:defRPr>
+    </a:lvl9pPr>
+  </p:notesStyle>
+</p:notesMaster>
+</file>
+
+<file path=ppt/notesSlides/notesSlide1.xml><?xml version="1.0" encoding="utf-8"?>
+<p:notes xmlns:a="http://schemas.openxmlformats.org/drawingml/2006/main" xmlns:r="http://schemas.openxmlformats.org/officeDocument/2006/relationships" xmlns:p="http://schemas.openxmlformats.org/presentationml/2006/main">
+  <p:cSld>
+    <p:spTree>
+      <p:nvGrpSpPr>
+        <p:cNvPr id="1" name=""/>
+        <p:cNvGrpSpPr/>
+        <p:nvPr/>
+      </p:nvGrpSpPr>
+      <p:grpSpPr>
+        <a:xfrm>
+          <a:off x="0" y="0"/>
+          <a:ext cx="0" cy="0"/>
+          <a:chOff x="0" y="0"/>
+          <a:chExt cx="0" cy="0"/>
+        </a:xfrm>
+      </p:grpSpPr>
+      <p:sp>
+        <p:nvSpPr>
+          <p:cNvPr id="2" name="Slide Image Placeholder 1"/>
+          <p:cNvSpPr>
+            <a:spLocks noGrp="1" noRot="1" noChangeAspect="1"/>
+          </p:cNvSpPr>
+          <p:nvPr>
+            <p:ph type="sldImg"/>
+          </p:nvPr>
+        </p:nvSpPr>
+        <p:spPr/>
+      </p:sp>
+      <p:sp>
+        <p:nvSpPr>
+          <p:cNvPr id="3" name="Notes Placeholder 2"/>
+          <p:cNvSpPr>
+            <a:spLocks noGrp="1"/>
+          </p:cNvSpPr>
+          <p:nvPr>
+            <p:ph type="body" idx="1"/>
+          </p:nvPr>
+        </p:nvSpPr>
+        <p:spPr/>
+        <p:txBody>
+          <a:bodyPr/>
+          <a:lstStyle/>
+          <a:p>
+            <a:endParaRPr lang="en-US" dirty="0"/>
+          </a:p>
+        </p:txBody>
+      </p:sp>
+      <p:sp>
+        <p:nvSpPr>
+          <p:cNvPr id="4" name="Slide Number Placeholder 3"/>
+          <p:cNvSpPr>
+            <a:spLocks noGrp="1"/>
+          </p:cNvSpPr>
+          <p:nvPr>
+            <p:ph type="sldNum" sz="quarter" idx="5"/>
+          </p:nvPr>
+        </p:nvSpPr>
+        <p:spPr/>
+        <p:txBody>
+          <a:bodyPr/>
+          <a:lstStyle/>
+          <a:p>
+            <a:fld id="{709456F3-6FBD-E749-9920-17BD4DF4BA60}" type="slidenum">
+              <a:rPr lang="en-US" smtClean="0"/>
+              <a:t>1</a:t>
+            </a:fld>
+            <a:endParaRPr lang="en-US"/>
+          </a:p>
+        </p:txBody>
+      </p:sp>
+    </p:spTree>
+    <p:extLst>
+      <p:ext uri="{BB962C8B-B14F-4D97-AF65-F5344CB8AC3E}">
+        <p14:creationId xmlns:p14="http://schemas.microsoft.com/office/powerpoint/2010/main" val="2602440631"/>
+      </p:ext>
+    </p:extLst>
+  </p:cSld>
+  <p:clrMapOvr>
+    <a:masterClrMapping/>
+  </p:clrMapOvr>
+</p:notes>
+</file>
+
 <file path=ppt/slideLayouts/slideLayout1.xml><?xml version="1.0" encoding="utf-8"?>
 <p:sldLayout xmlns:a="http://schemas.openxmlformats.org/drawingml/2006/main" xmlns:r="http://schemas.openxmlformats.org/officeDocument/2006/relationships" xmlns:p="http://schemas.openxmlformats.org/presentationml/2006/main" type="title" preserve="1">
   <p:cSld name="Title Slide">
@@ -383,10 +869,9 @@
           <a:lstStyle/>
           <a:p>
             <a:r>
-              <a:rPr lang="en-US" smtClean="0"/>
+              <a:rPr lang="en-US"/>
               <a:t>Click to edit Master title style</a:t>
             </a:r>
-            <a:endParaRPr lang="en-US"/>
           </a:p>
         </p:txBody>
       </p:sp>
@@ -502,10 +987,9 @@
           </a:lstStyle>
           <a:p>
             <a:r>
-              <a:rPr lang="en-US" smtClean="0"/>
+              <a:rPr lang="en-US"/>
               <a:t>Click to edit Master subtitle style</a:t>
             </a:r>
-            <a:endParaRPr lang="en-US"/>
           </a:p>
         </p:txBody>
       </p:sp>
@@ -526,7 +1010,7 @@
           <a:p>
             <a:fld id="{5BCAD085-E8A6-8845-BD4E-CB4CCA059FC4}" type="datetimeFigureOut">
               <a:rPr lang="en-US" smtClean="0"/>
-              <a:t>1/27/13</a:t>
+              <a:t>10/12/26</a:t>
             </a:fld>
             <a:endParaRPr lang="en-US"/>
           </a:p>
@@ -620,10 +1104,9 @@
           <a:lstStyle/>
           <a:p>
             <a:r>
-              <a:rPr lang="en-US" smtClean="0"/>
+              <a:rPr lang="en-US"/>
               <a:t>Click to edit Master title style</a:t>
             </a:r>
-            <a:endParaRPr lang="en-US"/>
           </a:p>
         </p:txBody>
       </p:sp>
@@ -644,38 +1127,37 @@
           <a:p>
             <a:pPr lvl="0"/>
             <a:r>
-              <a:rPr lang="en-US" smtClean="0"/>
+              <a:rPr lang="en-US"/>
               <a:t>Click to edit Master text styles</a:t>
             </a:r>
           </a:p>
           <a:p>
             <a:pPr lvl="1"/>
             <a:r>
-              <a:rPr lang="en-US" smtClean="0"/>
+              <a:rPr lang="en-US"/>
               <a:t>Second level</a:t>
             </a:r>
           </a:p>
           <a:p>
             <a:pPr lvl="2"/>
             <a:r>
-              <a:rPr lang="en-US" smtClean="0"/>
+              <a:rPr lang="en-US"/>
               <a:t>Third level</a:t>
             </a:r>
           </a:p>
           <a:p>
             <a:pPr lvl="3"/>
             <a:r>
-              <a:rPr lang="en-US" smtClean="0"/>
+              <a:rPr lang="en-US"/>
               <a:t>Fourth level</a:t>
             </a:r>
           </a:p>
           <a:p>
             <a:pPr lvl="4"/>
             <a:r>
-              <a:rPr lang="en-US" smtClean="0"/>
+              <a:rPr lang="en-US"/>
               <a:t>Fifth level</a:t>
             </a:r>
-            <a:endParaRPr lang="en-US"/>
           </a:p>
         </p:txBody>
       </p:sp>
@@ -696,7 +1178,7 @@
           <a:p>
             <a:fld id="{5BCAD085-E8A6-8845-BD4E-CB4CCA059FC4}" type="datetimeFigureOut">
               <a:rPr lang="en-US" smtClean="0"/>
-              <a:t>1/27/13</a:t>
+              <a:t>10/12/26</a:t>
             </a:fld>
             <a:endParaRPr lang="en-US"/>
           </a:p>
@@ -795,10 +1277,9 @@
           <a:lstStyle/>
           <a:p>
             <a:r>
-              <a:rPr lang="en-US" smtClean="0"/>
+              <a:rPr lang="en-US"/>
               <a:t>Click to edit Master title style</a:t>
             </a:r>
-            <a:endParaRPr lang="en-US"/>
           </a:p>
         </p:txBody>
       </p:sp>
@@ -824,38 +1305,37 @@
           <a:p>
             <a:pPr lvl="0"/>
             <a:r>
-              <a:rPr lang="en-US" smtClean="0"/>
+              <a:rPr lang="en-US"/>
               <a:t>Click to edit Master text styles</a:t>
             </a:r>
           </a:p>
           <a:p>
             <a:pPr lvl="1"/>
             <a:r>
-              <a:rPr lang="en-US" smtClean="0"/>
+              <a:rPr lang="en-US"/>
               <a:t>Second level</a:t>
             </a:r>
           </a:p>
           <a:p>
             <a:pPr lvl="2"/>
             <a:r>
-              <a:rPr lang="en-US" smtClean="0"/>
+              <a:rPr lang="en-US"/>
               <a:t>Third level</a:t>
             </a:r>
           </a:p>
           <a:p>
             <a:pPr lvl="3"/>
             <a:r>
-              <a:rPr lang="en-US" smtClean="0"/>
+              <a:rPr lang="en-US"/>
               <a:t>Fourth level</a:t>
             </a:r>
           </a:p>
           <a:p>
             <a:pPr lvl="4"/>
             <a:r>
-              <a:rPr lang="en-US" smtClean="0"/>
+              <a:rPr lang="en-US"/>
               <a:t>Fifth level</a:t>
             </a:r>
-            <a:endParaRPr lang="en-US"/>
           </a:p>
         </p:txBody>
       </p:sp>
@@ -876,7 +1356,7 @@
           <a:p>
             <a:fld id="{5BCAD085-E8A6-8845-BD4E-CB4CCA059FC4}" type="datetimeFigureOut">
               <a:rPr lang="en-US" smtClean="0"/>
-              <a:t>1/27/13</a:t>
+              <a:t>10/12/26</a:t>
             </a:fld>
             <a:endParaRPr lang="en-US"/>
           </a:p>
@@ -970,10 +1450,9 @@
           <a:lstStyle/>
           <a:p>
             <a:r>
-              <a:rPr lang="en-US" smtClean="0"/>
+              <a:rPr lang="en-US"/>
               <a:t>Click to edit Master title style</a:t>
             </a:r>
-            <a:endParaRPr lang="en-US"/>
           </a:p>
         </p:txBody>
       </p:sp>
@@ -994,38 +1473,37 @@
           <a:p>
             <a:pPr lvl="0"/>
             <a:r>
-              <a:rPr lang="en-US" smtClean="0"/>
+              <a:rPr lang="en-US"/>
               <a:t>Click to edit Master text styles</a:t>
             </a:r>
           </a:p>
           <a:p>
             <a:pPr lvl="1"/>
             <a:r>
-              <a:rPr lang="en-US" smtClean="0"/>
+              <a:rPr lang="en-US"/>
               <a:t>Second level</a:t>
             </a:r>
           </a:p>
           <a:p>
             <a:pPr lvl="2"/>
             <a:r>
-              <a:rPr lang="en-US" smtClean="0"/>
+              <a:rPr lang="en-US"/>
               <a:t>Third level</a:t>
             </a:r>
           </a:p>
           <a:p>
             <a:pPr lvl="3"/>
             <a:r>
-              <a:rPr lang="en-US" smtClean="0"/>
+              <a:rPr lang="en-US"/>
               <a:t>Fourth level</a:t>
             </a:r>
           </a:p>
           <a:p>
             <a:pPr lvl="4"/>
             <a:r>
-              <a:rPr lang="en-US" smtClean="0"/>
+              <a:rPr lang="en-US"/>
               <a:t>Fifth level</a:t>
             </a:r>
-            <a:endParaRPr lang="en-US"/>
           </a:p>
         </p:txBody>
       </p:sp>
@@ -1046,7 +1524,7 @@
           <a:p>
             <a:fld id="{5BCAD085-E8A6-8845-BD4E-CB4CCA059FC4}" type="datetimeFigureOut">
               <a:rPr lang="en-US" smtClean="0"/>
-              <a:t>1/27/13</a:t>
+              <a:t>10/12/26</a:t>
             </a:fld>
             <a:endParaRPr lang="en-US"/>
           </a:p>
@@ -1149,10 +1627,9 @@
           </a:lstStyle>
           <a:p>
             <a:r>
-              <a:rPr lang="en-US" smtClean="0"/>
+              <a:rPr lang="en-US"/>
               <a:t>Click to edit Master title style</a:t>
             </a:r>
-            <a:endParaRPr lang="en-US"/>
           </a:p>
         </p:txBody>
       </p:sp>
@@ -1269,7 +1746,7 @@
           <a:p>
             <a:pPr lvl="0"/>
             <a:r>
-              <a:rPr lang="en-US" smtClean="0"/>
+              <a:rPr lang="en-US"/>
               <a:t>Click to edit Master text styles</a:t>
             </a:r>
           </a:p>
@@ -1292,7 +1769,7 @@
           <a:p>
             <a:fld id="{5BCAD085-E8A6-8845-BD4E-CB4CCA059FC4}" type="datetimeFigureOut">
               <a:rPr lang="en-US" smtClean="0"/>
-              <a:t>1/27/13</a:t>
+              <a:t>10/12/26</a:t>
             </a:fld>
             <a:endParaRPr lang="en-US"/>
           </a:p>
@@ -1386,10 +1863,9 @@
           <a:lstStyle/>
           <a:p>
             <a:r>
-              <a:rPr lang="en-US" smtClean="0"/>
+              <a:rPr lang="en-US"/>
               <a:t>Click to edit Master title style</a:t>
             </a:r>
-            <a:endParaRPr lang="en-US"/>
           </a:p>
         </p:txBody>
       </p:sp>
@@ -1443,38 +1919,37 @@
           <a:p>
             <a:pPr lvl="0"/>
             <a:r>
-              <a:rPr lang="en-US" smtClean="0"/>
+              <a:rPr lang="en-US"/>
               <a:t>Click to edit Master text styles</a:t>
             </a:r>
           </a:p>
           <a:p>
             <a:pPr lvl="1"/>
             <a:r>
-              <a:rPr lang="en-US" smtClean="0"/>
+              <a:rPr lang="en-US"/>
               <a:t>Second level</a:t>
             </a:r>
           </a:p>
           <a:p>
             <a:pPr lvl="2"/>
             <a:r>
-              <a:rPr lang="en-US" smtClean="0"/>
+              <a:rPr lang="en-US"/>
               <a:t>Third level</a:t>
             </a:r>
           </a:p>
           <a:p>
             <a:pPr lvl="3"/>
             <a:r>
-              <a:rPr lang="en-US" smtClean="0"/>
+              <a:rPr lang="en-US"/>
               <a:t>Fourth level</a:t>
             </a:r>
           </a:p>
           <a:p>
             <a:pPr lvl="4"/>
             <a:r>
-              <a:rPr lang="en-US" smtClean="0"/>
+              <a:rPr lang="en-US"/>
               <a:t>Fifth level</a:t>
             </a:r>
-            <a:endParaRPr lang="en-US"/>
           </a:p>
         </p:txBody>
       </p:sp>
@@ -1528,38 +2003,37 @@
           <a:p>
             <a:pPr lvl="0"/>
             <a:r>
-              <a:rPr lang="en-US" smtClean="0"/>
+              <a:rPr lang="en-US"/>
               <a:t>Click to edit Master text styles</a:t>
             </a:r>
           </a:p>
           <a:p>
             <a:pPr lvl="1"/>
             <a:r>
-              <a:rPr lang="en-US" smtClean="0"/>
+              <a:rPr lang="en-US"/>
               <a:t>Second level</a:t>
             </a:r>
           </a:p>
           <a:p>
             <a:pPr lvl="2"/>
             <a:r>
-              <a:rPr lang="en-US" smtClean="0"/>
+              <a:rPr lang="en-US"/>
               <a:t>Third level</a:t>
             </a:r>
           </a:p>
           <a:p>
             <a:pPr lvl="3"/>
             <a:r>
-              <a:rPr lang="en-US" smtClean="0"/>
+              <a:rPr lang="en-US"/>
               <a:t>Fourth level</a:t>
             </a:r>
           </a:p>
           <a:p>
             <a:pPr lvl="4"/>
             <a:r>
-              <a:rPr lang="en-US" smtClean="0"/>
+              <a:rPr lang="en-US"/>
               <a:t>Fifth level</a:t>
             </a:r>
-            <a:endParaRPr lang="en-US"/>
           </a:p>
         </p:txBody>
       </p:sp>
@@ -1580,7 +2054,7 @@
           <a:p>
             <a:fld id="{5BCAD085-E8A6-8845-BD4E-CB4CCA059FC4}" type="datetimeFigureOut">
               <a:rPr lang="en-US" smtClean="0"/>
-              <a:t>1/27/13</a:t>
+              <a:t>10/12/26</a:t>
             </a:fld>
             <a:endParaRPr lang="en-US"/>
           </a:p>
@@ -1678,10 +2152,9 @@
           </a:lstStyle>
           <a:p>
             <a:r>
-              <a:rPr lang="en-US" smtClean="0"/>
+              <a:rPr lang="en-US"/>
               <a:t>Click to edit Master title style</a:t>
             </a:r>
-            <a:endParaRPr lang="en-US"/>
           </a:p>
         </p:txBody>
       </p:sp>
@@ -1744,7 +2217,7 @@
           <a:p>
             <a:pPr lvl="0"/>
             <a:r>
-              <a:rPr lang="en-US" smtClean="0"/>
+              <a:rPr lang="en-US"/>
               <a:t>Click to edit Master text styles</a:t>
             </a:r>
           </a:p>
@@ -1800,38 +2273,37 @@
           <a:p>
             <a:pPr lvl="0"/>
             <a:r>
-              <a:rPr lang="en-US" smtClean="0"/>
+              <a:rPr lang="en-US"/>
               <a:t>Click to edit Master text styles</a:t>
             </a:r>
           </a:p>
           <a:p>
             <a:pPr lvl="1"/>
             <a:r>
-              <a:rPr lang="en-US" smtClean="0"/>
+              <a:rPr lang="en-US"/>
               <a:t>Second level</a:t>
             </a:r>
           </a:p>
           <a:p>
             <a:pPr lvl="2"/>
             <a:r>
-              <a:rPr lang="en-US" smtClean="0"/>
+              <a:rPr lang="en-US"/>
               <a:t>Third level</a:t>
             </a:r>
           </a:p>
           <a:p>
             <a:pPr lvl="3"/>
             <a:r>
-              <a:rPr lang="en-US" smtClean="0"/>
+              <a:rPr lang="en-US"/>
               <a:t>Fourth level</a:t>
             </a:r>
           </a:p>
           <a:p>
             <a:pPr lvl="4"/>
             <a:r>
-              <a:rPr lang="en-US" smtClean="0"/>
+              <a:rPr lang="en-US"/>
               <a:t>Fifth level</a:t>
             </a:r>
-            <a:endParaRPr lang="en-US"/>
           </a:p>
         </p:txBody>
       </p:sp>
@@ -1894,7 +2366,7 @@
           <a:p>
             <a:pPr lvl="0"/>
             <a:r>
-              <a:rPr lang="en-US" smtClean="0"/>
+              <a:rPr lang="en-US"/>
               <a:t>Click to edit Master text styles</a:t>
             </a:r>
           </a:p>
@@ -1950,38 +2422,37 @@
           <a:p>
             <a:pPr lvl="0"/>
             <a:r>
-              <a:rPr lang="en-US" smtClean="0"/>
+              <a:rPr lang="en-US"/>
               <a:t>Click to edit Master text styles</a:t>
             </a:r>
           </a:p>
           <a:p>
             <a:pPr lvl="1"/>
             <a:r>
-              <a:rPr lang="en-US" smtClean="0"/>
+              <a:rPr lang="en-US"/>
               <a:t>Second level</a:t>
             </a:r>
           </a:p>
           <a:p>
             <a:pPr lvl="2"/>
             <a:r>
-              <a:rPr lang="en-US" smtClean="0"/>
+              <a:rPr lang="en-US"/>
               <a:t>Third level</a:t>
             </a:r>
           </a:p>
           <a:p>
             <a:pPr lvl="3"/>
             <a:r>
-              <a:rPr lang="en-US" smtClean="0"/>
+              <a:rPr lang="en-US"/>
               <a:t>Fourth level</a:t>
             </a:r>
           </a:p>
           <a:p>
             <a:pPr lvl="4"/>
             <a:r>
-              <a:rPr lang="en-US" smtClean="0"/>
+              <a:rPr lang="en-US"/>
               <a:t>Fifth level</a:t>
             </a:r>
-            <a:endParaRPr lang="en-US"/>
           </a:p>
         </p:txBody>
       </p:sp>
@@ -2002,7 +2473,7 @@
           <a:p>
             <a:fld id="{5BCAD085-E8A6-8845-BD4E-CB4CCA059FC4}" type="datetimeFigureOut">
               <a:rPr lang="en-US" smtClean="0"/>
-              <a:t>1/27/13</a:t>
+              <a:t>10/12/26</a:t>
             </a:fld>
             <a:endParaRPr lang="en-US"/>
           </a:p>
@@ -2096,10 +2567,9 @@
           <a:lstStyle/>
           <a:p>
             <a:r>
-              <a:rPr lang="en-US" smtClean="0"/>
+              <a:rPr lang="en-US"/>
               <a:t>Click to edit Master title style</a:t>
             </a:r>
-            <a:endParaRPr lang="en-US"/>
           </a:p>
         </p:txBody>
       </p:sp>
@@ -2120,7 +2590,7 @@
           <a:p>
             <a:fld id="{5BCAD085-E8A6-8845-BD4E-CB4CCA059FC4}" type="datetimeFigureOut">
               <a:rPr lang="en-US" smtClean="0"/>
-              <a:t>1/27/13</a:t>
+              <a:t>10/12/26</a:t>
             </a:fld>
             <a:endParaRPr lang="en-US"/>
           </a:p>
@@ -2215,7 +2685,7 @@
           <a:p>
             <a:fld id="{5BCAD085-E8A6-8845-BD4E-CB4CCA059FC4}" type="datetimeFigureOut">
               <a:rPr lang="en-US" smtClean="0"/>
-              <a:t>1/27/13</a:t>
+              <a:t>10/12/26</a:t>
             </a:fld>
             <a:endParaRPr lang="en-US"/>
           </a:p>
@@ -2318,10 +2788,9 @@
           </a:lstStyle>
           <a:p>
             <a:r>
-              <a:rPr lang="en-US" smtClean="0"/>
+              <a:rPr lang="en-US"/>
               <a:t>Click to edit Master title style</a:t>
             </a:r>
-            <a:endParaRPr lang="en-US"/>
           </a:p>
         </p:txBody>
       </p:sp>
@@ -2375,38 +2844,37 @@
           <a:p>
             <a:pPr lvl="0"/>
             <a:r>
-              <a:rPr lang="en-US" smtClean="0"/>
+              <a:rPr lang="en-US"/>
               <a:t>Click to edit Master text styles</a:t>
             </a:r>
           </a:p>
           <a:p>
             <a:pPr lvl="1"/>
             <a:r>
-              <a:rPr lang="en-US" smtClean="0"/>
+              <a:rPr lang="en-US"/>
               <a:t>Second level</a:t>
             </a:r>
           </a:p>
           <a:p>
             <a:pPr lvl="2"/>
             <a:r>
-              <a:rPr lang="en-US" smtClean="0"/>
+              <a:rPr lang="en-US"/>
               <a:t>Third level</a:t>
             </a:r>
           </a:p>
           <a:p>
             <a:pPr lvl="3"/>
             <a:r>
-              <a:rPr lang="en-US" smtClean="0"/>
+              <a:rPr lang="en-US"/>
               <a:t>Fourth level</a:t>
             </a:r>
           </a:p>
           <a:p>
             <a:pPr lvl="4"/>
             <a:r>
-              <a:rPr lang="en-US" smtClean="0"/>
+              <a:rPr lang="en-US"/>
               <a:t>Fifth level</a:t>
             </a:r>
-            <a:endParaRPr lang="en-US"/>
           </a:p>
         </p:txBody>
       </p:sp>
@@ -2469,7 +2937,7 @@
           <a:p>
             <a:pPr lvl="0"/>
             <a:r>
-              <a:rPr lang="en-US" smtClean="0"/>
+              <a:rPr lang="en-US"/>
               <a:t>Click to edit Master text styles</a:t>
             </a:r>
           </a:p>
@@ -2492,7 +2960,7 @@
           <a:p>
             <a:fld id="{5BCAD085-E8A6-8845-BD4E-CB4CCA059FC4}" type="datetimeFigureOut">
               <a:rPr lang="en-US" smtClean="0"/>
-              <a:t>1/27/13</a:t>
+              <a:t>10/12/26</a:t>
             </a:fld>
             <a:endParaRPr lang="en-US"/>
           </a:p>
@@ -2595,10 +3063,9 @@
           </a:lstStyle>
           <a:p>
             <a:r>
-              <a:rPr lang="en-US" smtClean="0"/>
+              <a:rPr lang="en-US"/>
               <a:t>Click to edit Master title style</a:t>
             </a:r>
-            <a:endParaRPr lang="en-US"/>
           </a:p>
         </p:txBody>
       </p:sp>
@@ -2722,7 +3189,7 @@
           <a:p>
             <a:pPr lvl="0"/>
             <a:r>
-              <a:rPr lang="en-US" smtClean="0"/>
+              <a:rPr lang="en-US"/>
               <a:t>Click to edit Master text styles</a:t>
             </a:r>
           </a:p>
@@ -2745,7 +3212,7 @@
           <a:p>
             <a:fld id="{5BCAD085-E8A6-8845-BD4E-CB4CCA059FC4}" type="datetimeFigureOut">
               <a:rPr lang="en-US" smtClean="0"/>
-              <a:t>1/27/13</a:t>
+              <a:t>10/12/26</a:t>
             </a:fld>
             <a:endParaRPr lang="en-US"/>
           </a:p>
@@ -2854,10 +3321,9 @@
           <a:lstStyle/>
           <a:p>
             <a:r>
-              <a:rPr lang="en-US" smtClean="0"/>
+              <a:rPr lang="en-US"/>
               <a:t>Click to edit Master title style</a:t>
             </a:r>
-            <a:endParaRPr lang="en-US"/>
           </a:p>
         </p:txBody>
       </p:sp>
@@ -2888,38 +3354,37 @@
           <a:p>
             <a:pPr lvl="0"/>
             <a:r>
-              <a:rPr lang="en-US" smtClean="0"/>
+              <a:rPr lang="en-US"/>
               <a:t>Click to edit Master text styles</a:t>
             </a:r>
           </a:p>
           <a:p>
             <a:pPr lvl="1"/>
             <a:r>
-              <a:rPr lang="en-US" smtClean="0"/>
+              <a:rPr lang="en-US"/>
               <a:t>Second level</a:t>
             </a:r>
           </a:p>
           <a:p>
             <a:pPr lvl="2"/>
             <a:r>
-              <a:rPr lang="en-US" smtClean="0"/>
+              <a:rPr lang="en-US"/>
               <a:t>Third level</a:t>
             </a:r>
           </a:p>
           <a:p>
             <a:pPr lvl="3"/>
             <a:r>
-              <a:rPr lang="en-US" smtClean="0"/>
+              <a:rPr lang="en-US"/>
               <a:t>Fourth level</a:t>
             </a:r>
           </a:p>
           <a:p>
             <a:pPr lvl="4"/>
             <a:r>
-              <a:rPr lang="en-US" smtClean="0"/>
+              <a:rPr lang="en-US"/>
               <a:t>Fifth level</a:t>
             </a:r>
-            <a:endParaRPr lang="en-US"/>
           </a:p>
         </p:txBody>
       </p:sp>
@@ -2958,7 +3423,7 @@
           <a:p>
             <a:fld id="{5BCAD085-E8A6-8845-BD4E-CB4CCA059FC4}" type="datetimeFigureOut">
               <a:rPr lang="en-US" smtClean="0"/>
-              <a:t>1/27/13</a:t>
+              <a:t>10/12/26</a:t>
             </a:fld>
             <a:endParaRPr lang="en-US"/>
           </a:p>
@@ -3317,7 +3782,7 @@
 </file>
 
 <file path=ppt/slides/slide1.xml><?xml version="1.0" encoding="utf-8"?>
-<p:sld xmlns:a="http://schemas.openxmlformats.org/drawingml/2006/main" xmlns:p="http://schemas.openxmlformats.org/presentationml/2006/main" xmlns:r="http://schemas.openxmlformats.org/officeDocument/2006/relationships">
+<p:sld xmlns:a="http://schemas.openxmlformats.org/drawingml/2006/main" xmlns:r="http://schemas.openxmlformats.org/officeDocument/2006/relationships" xmlns:p="http://schemas.openxmlformats.org/presentationml/2006/main">
   <p:cSld>
     <p:spTree>
       <p:nvGrpSpPr>
@@ -3325,7 +3790,14 @@
         <p:cNvGrpSpPr/>
         <p:nvPr/>
       </p:nvGrpSpPr>
-      <p:grpSpPr/>
+      <p:grpSpPr>
+        <a:xfrm>
+          <a:off x="0" y="0"/>
+          <a:ext cx="0" cy="0"/>
+          <a:chOff x="0" y="0"/>
+          <a:chExt cx="0" cy="0"/>
+        </a:xfrm>
+      </p:grpSpPr>
       <p:sp>
         <p:nvSpPr>
           <p:cNvPr id="2" name="Rectangle 1"/>
@@ -3363,7 +3835,7 @@
           </a:fontRef>
         </p:style>
         <p:txBody>
-          <a:bodyPr rtlCol="0" anchor="ctr" wrap="square" lIns="365760" rIns="365760"/>
+          <a:bodyPr wrap="square" lIns="365760" rIns="365760" rtlCol="0" anchor="ctr"/>
           <a:lstStyle/>
           <a:p>
             <a:pPr algn="ctr">
@@ -3372,7 +3844,7 @@
               </a:spcAft>
             </a:pPr>
             <a:r>
-              <a:rPr sz="9600" b="1" i="0">
+              <a:rPr sz="9500" b="1" i="0" dirty="0">
                 <a:solidFill>
                   <a:srgbClr val="FFFFFF"/>
                 </a:solidFill>
@@ -3388,13 +3860,58 @@
               </a:spcAft>
             </a:pPr>
             <a:r>
-              <a:rPr sz="3000" b="0" i="0">
+              <a:rPr lang="en-US" sz="7000" b="0" i="0" dirty="0">
                 <a:solidFill>
                   <a:srgbClr val="CFE0F0"/>
                 </a:solidFill>
                 <a:latin typeface="Calibri"/>
               </a:rPr>
-              <a:t>Nathan Garrett  ·  Accounting and Information Systems  ·  West Virginia University</a:t>
+              <a:t>Bob Smith,</a:t>
+            </a:r>
+            <a:r>
+              <a:rPr sz="7000" b="0" i="0" dirty="0">
+                <a:solidFill>
+                  <a:srgbClr val="CFE0F0"/>
+                </a:solidFill>
+                <a:latin typeface="Calibri"/>
+              </a:rPr>
+              <a:t> </a:t>
+            </a:r>
+            <a:r>
+              <a:rPr lang="en-US" sz="7000" b="0" i="0" dirty="0" err="1">
+                <a:solidFill>
+                  <a:srgbClr val="CFE0F0"/>
+                </a:solidFill>
+                <a:latin typeface="Calibri"/>
+              </a:rPr>
+              <a:t>bsmith@mail.wvu.edu</a:t>
+            </a:r>
+            <a:r>
+              <a:rPr lang="en-US" sz="7000" dirty="0">
+                <a:solidFill>
+                  <a:srgbClr val="CFE0F0"/>
+                </a:solidFill>
+                <a:latin typeface="Calibri"/>
+              </a:rPr>
+              <a:t>,</a:t>
+            </a:r>
+            <a:r>
+              <a:rPr lang="en-US" sz="7000" b="0" i="0" dirty="0">
+                <a:solidFill>
+                  <a:srgbClr val="CFE0F0"/>
+                </a:solidFill>
+                <a:latin typeface="Calibri"/>
+              </a:rPr>
+              <a:t> </a:t>
+            </a:r>
+            <a:r>
+              <a:rPr sz="7000" b="0" i="0" dirty="0">
+                <a:solidFill>
+                  <a:srgbClr val="CFE0F0"/>
+                </a:solidFill>
+                <a:latin typeface="Calibri"/>
+              </a:rPr>
+              <a:t>West Virginia University</a:t>
             </a:r>
           </a:p>
         </p:txBody>
@@ -3438,7 +3955,7 @@
           </a:fontRef>
         </p:style>
         <p:txBody>
-          <a:bodyPr rtlCol="0" anchor="ctr" wrap="square" lIns="365760" rIns="365760"/>
+          <a:bodyPr wrap="square" lIns="365760" rIns="365760" rtlCol="0" anchor="ctr"/>
           <a:lstStyle/>
           <a:p>
             <a:pPr algn="ctr">
@@ -3447,13 +3964,85 @@
               </a:spcAft>
             </a:pPr>
             <a:r>
-              <a:rPr sz="4600" b="1" i="0">
+              <a:rPr sz="4600" b="1" i="0" dirty="0">
                 <a:solidFill>
                   <a:srgbClr val="0F5FA6"/>
                 </a:solidFill>
                 <a:latin typeface="Calibri"/>
               </a:rPr>
-              <a:t>Gifts labeled from Santa cost $0.42 more than gifts labeled from parents — 1.2% of the average gift. Detectable, but meaningless.</a:t>
+              <a:t>Gifts labeled from </a:t>
+            </a:r>
+            <a:r>
+              <a:rPr sz="6000" b="1" i="0" dirty="0">
+                <a:solidFill>
+                  <a:srgbClr val="0F5FA6"/>
+                </a:solidFill>
+                <a:latin typeface="Calibri"/>
+              </a:rPr>
+              <a:t>Santa</a:t>
+            </a:r>
+            <a:r>
+              <a:rPr sz="4600" b="1" i="0" dirty="0">
+                <a:solidFill>
+                  <a:srgbClr val="0F5FA6"/>
+                </a:solidFill>
+                <a:latin typeface="Calibri"/>
+              </a:rPr>
+              <a:t> cost $0.42 more </a:t>
+            </a:r>
+            <a:r>
+              <a:rPr lang="en-US" sz="4600" b="1" i="0" dirty="0">
+                <a:solidFill>
+                  <a:srgbClr val="0F5FA6"/>
+                </a:solidFill>
+                <a:latin typeface="Calibri"/>
+              </a:rPr>
+              <a:t>then parents (</a:t>
+            </a:r>
+            <a:r>
+              <a:rPr sz="4600" b="1" i="0" dirty="0">
+                <a:solidFill>
+                  <a:srgbClr val="0F5FA6"/>
+                </a:solidFill>
+                <a:latin typeface="Calibri"/>
+              </a:rPr>
+              <a:t>1.2%</a:t>
+            </a:r>
+            <a:r>
+              <a:rPr lang="en-US" sz="4600" b="1" i="0" dirty="0">
+                <a:solidFill>
+                  <a:srgbClr val="0F5FA6"/>
+                </a:solidFill>
+                <a:latin typeface="Calibri"/>
+              </a:rPr>
+              <a:t>)</a:t>
+            </a:r>
+            <a:r>
+              <a:rPr sz="4600" b="1" i="0" dirty="0">
+                <a:solidFill>
+                  <a:srgbClr val="0F5FA6"/>
+                </a:solidFill>
+                <a:latin typeface="Calibri"/>
+              </a:rPr>
+              <a:t>. </a:t>
+            </a:r>
+            <a:r>
+              <a:rPr lang="en-US" sz="4600" b="1" i="0" dirty="0">
+                <a:solidFill>
+                  <a:srgbClr val="0F5FA6"/>
+                </a:solidFill>
+                <a:latin typeface="Calibri"/>
+              </a:rPr>
+              <a:t>Differences are statistically significant</a:t>
+            </a:r>
+            <a:r>
+              <a:rPr sz="4600" b="1" i="0" dirty="0">
+                <a:solidFill>
+                  <a:srgbClr val="0F5FA6"/>
+                </a:solidFill>
+                <a:latin typeface="Calibri"/>
+              </a:rPr>
+              <a:t>, but meaningless.</a:t>
             </a:r>
           </a:p>
         </p:txBody>
@@ -3467,7 +4056,7 @@
         <p:spPr>
           <a:xfrm>
             <a:off x="1371600" y="8595360"/>
-            <a:ext cx="12801600" cy="822960"/>
+            <a:ext cx="12801600" cy="846386"/>
           </a:xfrm>
           <a:prstGeom prst="rect">
             <a:avLst/>
@@ -3475,7 +4064,7 @@
           <a:noFill/>
         </p:spPr>
         <p:txBody>
-          <a:bodyPr wrap="square" lIns="0" rIns="0" tIns="0" bIns="0" anchor="t">
+          <a:bodyPr wrap="square" lIns="0" tIns="0" rIns="0" bIns="0" anchor="t">
             <a:spAutoFit/>
           </a:bodyPr>
           <a:lstStyle/>
@@ -3486,7 +4075,7 @@
               </a:spcAft>
             </a:pPr>
             <a:r>
-              <a:rPr sz="4000" b="1" i="0">
+              <a:rPr sz="5500" b="1" i="0" dirty="0">
                 <a:solidFill>
                   <a:srgbClr val="0F5FA6"/>
                 </a:solidFill>
@@ -3506,7 +4095,7 @@
         <p:spPr>
           <a:xfrm>
             <a:off x="1371600" y="9692640"/>
-            <a:ext cx="12801600" cy="2377440"/>
+            <a:ext cx="12801600" cy="1846659"/>
           </a:xfrm>
           <a:prstGeom prst="rect">
             <a:avLst/>
@@ -3514,7 +4103,7 @@
           <a:noFill/>
         </p:spPr>
         <p:txBody>
-          <a:bodyPr wrap="square" lIns="0" rIns="0" tIns="0" bIns="0" anchor="t">
+          <a:bodyPr wrap="square" lIns="0" tIns="0" rIns="0" bIns="0" anchor="t">
             <a:spAutoFit/>
           </a:bodyPr>
           <a:lstStyle/>
@@ -3525,7 +4114,7 @@
               </a:spcAft>
             </a:pPr>
             <a:r>
-              <a:rPr sz="2600" b="0" i="0">
+              <a:rPr sz="4000" b="0" i="0" dirty="0">
                 <a:solidFill>
                   <a:srgbClr val="222222"/>
                 </a:solidFill>
@@ -3545,7 +4134,7 @@
         <p:spPr>
           <a:xfrm>
             <a:off x="1371600" y="12801600"/>
-            <a:ext cx="12801600" cy="822960"/>
+            <a:ext cx="12801600" cy="846386"/>
           </a:xfrm>
           <a:prstGeom prst="rect">
             <a:avLst/>
@@ -3553,7 +4142,7 @@
           <a:noFill/>
         </p:spPr>
         <p:txBody>
-          <a:bodyPr wrap="square" lIns="0" rIns="0" tIns="0" bIns="0" anchor="t">
+          <a:bodyPr wrap="square" lIns="0" tIns="0" rIns="0" bIns="0" anchor="t">
             <a:spAutoFit/>
           </a:bodyPr>
           <a:lstStyle/>
@@ -3564,7 +4153,7 @@
               </a:spcAft>
             </a:pPr>
             <a:r>
-              <a:rPr sz="4000" b="1" i="0">
+              <a:rPr sz="5500" b="1" i="0" dirty="0">
                 <a:solidFill>
                   <a:srgbClr val="0F5FA6"/>
                 </a:solidFill>
@@ -3584,7 +4173,7 @@
         <p:spPr>
           <a:xfrm>
             <a:off x="1371600" y="13898880"/>
-            <a:ext cx="12801600" cy="5120640"/>
+            <a:ext cx="12801600" cy="4308872"/>
           </a:xfrm>
           <a:prstGeom prst="rect">
             <a:avLst/>
@@ -3592,7 +4181,7 @@
           <a:noFill/>
         </p:spPr>
         <p:txBody>
-          <a:bodyPr wrap="square" lIns="0" rIns="0" tIns="0" bIns="0" anchor="t">
+          <a:bodyPr wrap="square" lIns="0" tIns="0" rIns="0" bIns="0" anchor="t">
             <a:spAutoFit/>
           </a:bodyPr>
           <a:lstStyle/>
@@ -3603,7 +4192,7 @@
               </a:spcAft>
             </a:pPr>
             <a:r>
-              <a:rPr sz="2600" b="0" i="0">
+              <a:rPr sz="4000" b="0" i="0">
                 <a:solidFill>
                   <a:srgbClr val="222222"/>
                 </a:solidFill>
@@ -3619,7 +4208,7 @@
               </a:spcAft>
             </a:pPr>
             <a:r>
-              <a:rPr sz="2600" b="0" i="0">
+              <a:rPr sz="4000" b="0" i="0">
                 <a:solidFill>
                   <a:srgbClr val="222222"/>
                 </a:solidFill>
@@ -3635,7 +4224,7 @@
               </a:spcAft>
             </a:pPr>
             <a:r>
-              <a:rPr sz="2600" b="0" i="0">
+              <a:rPr sz="4000" b="0" i="0">
                 <a:solidFill>
                   <a:srgbClr val="222222"/>
                 </a:solidFill>
@@ -3651,7 +4240,7 @@
               </a:spcAft>
             </a:pPr>
             <a:r>
-              <a:rPr sz="2600" b="0" i="0">
+              <a:rPr sz="4000" b="0" i="0">
                 <a:solidFill>
                   <a:srgbClr val="222222"/>
                 </a:solidFill>
@@ -3667,7 +4256,7 @@
               </a:spcAft>
             </a:pPr>
             <a:r>
-              <a:rPr sz="2600" b="0" i="0">
+              <a:rPr sz="4000" b="0" i="0">
                 <a:solidFill>
                   <a:srgbClr val="222222"/>
                 </a:solidFill>
@@ -3687,7 +4276,7 @@
         <p:spPr>
           <a:xfrm>
             <a:off x="1371600" y="19568160"/>
-            <a:ext cx="12801600" cy="822960"/>
+            <a:ext cx="12801600" cy="846386"/>
           </a:xfrm>
           <a:prstGeom prst="rect">
             <a:avLst/>
@@ -3695,7 +4284,7 @@
           <a:noFill/>
         </p:spPr>
         <p:txBody>
-          <a:bodyPr wrap="square" lIns="0" rIns="0" tIns="0" bIns="0" anchor="t">
+          <a:bodyPr wrap="square" lIns="0" tIns="0" rIns="0" bIns="0" anchor="t">
             <a:spAutoFit/>
           </a:bodyPr>
           <a:lstStyle/>
@@ -3706,7 +4295,7 @@
               </a:spcAft>
             </a:pPr>
             <a:r>
-              <a:rPr sz="4000" b="1" i="0">
+              <a:rPr sz="5500" b="1" i="0">
                 <a:solidFill>
                   <a:srgbClr val="0F5FA6"/>
                 </a:solidFill>
@@ -3726,7 +4315,7 @@
         <p:spPr>
           <a:xfrm>
             <a:off x="1371600" y="20665440"/>
-            <a:ext cx="12801600" cy="2560320"/>
+            <a:ext cx="12801600" cy="1231106"/>
           </a:xfrm>
           <a:prstGeom prst="rect">
             <a:avLst/>
@@ -3734,7 +4323,7 @@
           <a:noFill/>
         </p:spPr>
         <p:txBody>
-          <a:bodyPr wrap="square" lIns="0" rIns="0" tIns="0" bIns="0" anchor="t">
+          <a:bodyPr wrap="square" lIns="0" tIns="0" rIns="0" bIns="0" anchor="t">
             <a:spAutoFit/>
           </a:bodyPr>
           <a:lstStyle/>
@@ -3745,13 +4334,13 @@
               </a:spcAft>
             </a:pPr>
             <a:r>
-              <a:rPr sz="2600" b="0" i="0">
+              <a:rPr sz="4000" b="0" i="0" dirty="0">
                 <a:solidFill>
                   <a:srgbClr val="222222"/>
                 </a:solidFill>
                 <a:latin typeface="Calibri"/>
               </a:rPr>
-              <a:t>Ordinary least squares predicting sale price in dollars from the giver label, item type, and days until Christmas. The outcome is continuous, so OLS and R² are the right tools here.</a:t>
+              <a:t>Ordinary least squares predicting sale price in dollars from the giver label, item type, and days until Christmas. </a:t>
             </a:r>
           </a:p>
         </p:txBody>
@@ -3765,7 +4354,7 @@
         <p:spPr>
           <a:xfrm>
             <a:off x="1371600" y="23957280"/>
-            <a:ext cx="12801600" cy="822960"/>
+            <a:ext cx="12801600" cy="846386"/>
           </a:xfrm>
           <a:prstGeom prst="rect">
             <a:avLst/>
@@ -3773,7 +4362,7 @@
           <a:noFill/>
         </p:spPr>
         <p:txBody>
-          <a:bodyPr wrap="square" lIns="0" rIns="0" tIns="0" bIns="0" anchor="t">
+          <a:bodyPr wrap="square" lIns="0" tIns="0" rIns="0" bIns="0" anchor="t">
             <a:spAutoFit/>
           </a:bodyPr>
           <a:lstStyle/>
@@ -3784,7 +4373,7 @@
               </a:spcAft>
             </a:pPr>
             <a:r>
-              <a:rPr sz="4000" b="1" i="0">
+              <a:rPr sz="5500" b="1" i="0">
                 <a:solidFill>
                   <a:srgbClr val="0F5FA6"/>
                 </a:solidFill>
@@ -3804,7 +4393,7 @@
         <p:spPr>
           <a:xfrm>
             <a:off x="1371600" y="25054560"/>
-            <a:ext cx="12801600" cy="5852160"/>
+            <a:ext cx="12801600" cy="3616375"/>
           </a:xfrm>
           <a:prstGeom prst="rect">
             <a:avLst/>
@@ -3812,7 +4401,7 @@
           <a:noFill/>
         </p:spPr>
         <p:txBody>
-          <a:bodyPr wrap="square" lIns="0" rIns="0" tIns="0" bIns="0" anchor="t">
+          <a:bodyPr wrap="square" lIns="0" tIns="0" rIns="0" bIns="0" anchor="t">
             <a:spAutoFit/>
           </a:bodyPr>
           <a:lstStyle/>
@@ -3823,7 +4412,7 @@
               </a:spcAft>
             </a:pPr>
             <a:r>
-              <a:rPr sz="2600" b="0" i="0">
+              <a:rPr sz="4000" b="0" i="0" dirty="0">
                 <a:solidFill>
                   <a:srgbClr val="222222"/>
                 </a:solidFill>
@@ -3839,7 +4428,7 @@
               </a:spcAft>
             </a:pPr>
             <a:r>
-              <a:rPr sz="2600" b="0" i="0">
+              <a:rPr sz="4000" b="0" i="0" dirty="0">
                 <a:solidFill>
                   <a:srgbClr val="222222"/>
                 </a:solidFill>
@@ -3855,7 +4444,7 @@
               </a:spcAft>
             </a:pPr>
             <a:r>
-              <a:rPr sz="2600" b="0" i="0">
+              <a:rPr sz="4000" b="0" i="0" dirty="0">
                 <a:solidFill>
                   <a:srgbClr val="222222"/>
                 </a:solidFill>
@@ -3871,7 +4460,7 @@
               </a:spcAft>
             </a:pPr>
             <a:r>
-              <a:rPr sz="2600" b="0" i="0">
+              <a:rPr sz="4000" b="0" i="0" dirty="0">
                 <a:solidFill>
                   <a:srgbClr val="222222"/>
                 </a:solidFill>
@@ -3891,7 +4480,7 @@
         <p:spPr>
           <a:xfrm>
             <a:off x="15544800" y="8595360"/>
-            <a:ext cx="16002000" cy="822960"/>
+            <a:ext cx="16002000" cy="846386"/>
           </a:xfrm>
           <a:prstGeom prst="rect">
             <a:avLst/>
@@ -3899,7 +4488,7 @@
           <a:noFill/>
         </p:spPr>
         <p:txBody>
-          <a:bodyPr wrap="square" lIns="0" rIns="0" tIns="0" bIns="0" anchor="t">
+          <a:bodyPr wrap="square" lIns="0" tIns="0" rIns="0" bIns="0" anchor="t">
             <a:spAutoFit/>
           </a:bodyPr>
           <a:lstStyle/>
@@ -3910,7 +4499,7 @@
               </a:spcAft>
             </a:pPr>
             <a:r>
-              <a:rPr sz="4000" b="1" i="0">
+              <a:rPr sz="5500" b="1" i="0">
                 <a:solidFill>
                   <a:srgbClr val="0F5FA6"/>
                 </a:solidFill>
@@ -3927,7 +4516,13 @@
           <p:cNvGraphicFramePr>
             <a:graphicFrameLocks noGrp="1"/>
           </p:cNvGraphicFramePr>
-          <p:nvPr/>
+          <p:nvPr>
+            <p:extLst>
+              <p:ext uri="{D42A27DB-BD31-4B8C-83A1-F6EECF244321}">
+                <p14:modId xmlns:p14="http://schemas.microsoft.com/office/powerpoint/2010/main" val="3002706684"/>
+              </p:ext>
+            </p:extLst>
+          </p:nvPr>
         </p:nvGraphicFramePr>
         <p:xfrm>
           <a:off x="15544800" y="9692640"/>
@@ -3935,7 +4530,7 @@
         </p:xfrm>
         <a:graphic>
           <a:graphicData uri="http://schemas.openxmlformats.org/drawingml/2006/chart">
-            <c:chart xmlns:c="http://schemas.openxmlformats.org/drawingml/2006/chart" r:id="rId2"/>
+            <c:chart xmlns:c="http://schemas.openxmlformats.org/drawingml/2006/chart" xmlns:r="http://schemas.openxmlformats.org/officeDocument/2006/relationships" r:id="rId3"/>
           </a:graphicData>
         </a:graphic>
       </p:graphicFrame>
@@ -3956,7 +4551,7 @@
           <a:noFill/>
         </p:spPr>
         <p:txBody>
-          <a:bodyPr wrap="square" lIns="0" rIns="0" tIns="0" bIns="0" anchor="t">
+          <a:bodyPr wrap="square" lIns="0" tIns="0" rIns="0" bIns="0" anchor="t">
             <a:spAutoFit/>
           </a:bodyPr>
           <a:lstStyle/>
@@ -4015,7 +4610,7 @@
           </a:fontRef>
         </p:style>
         <p:txBody>
-          <a:bodyPr rtlCol="0" anchor="ctr" wrap="square" lIns="457200" rIns="457200" tIns="365760" bIns="365760"/>
+          <a:bodyPr wrap="square" lIns="457200" tIns="365760" rIns="457200" bIns="365760" rtlCol="0" anchor="ctr"/>
           <a:lstStyle/>
           <a:p>
             <a:pPr algn="l">
@@ -4024,7 +4619,7 @@
               </a:spcAft>
             </a:pPr>
             <a:r>
-              <a:rPr sz="3000" b="1" i="0">
+              <a:rPr sz="4800" b="1" i="0" dirty="0">
                 <a:solidFill>
                   <a:srgbClr val="0F5FA6"/>
                 </a:solidFill>
@@ -4040,14 +4635,29 @@
               </a:spcAft>
             </a:pPr>
             <a:r>
-              <a:rPr sz="2600" b="0" i="0">
+              <a:rPr sz="4400" b="0" i="0" dirty="0">
                 <a:solidFill>
                   <a:srgbClr val="222222"/>
                 </a:solidFill>
                 <a:latin typeface="Calibri"/>
               </a:rPr>
-              <a:t>The Santa coefficient is $0.42 (SE $0.011, p &lt; 0.001). With 2.6 million observations even a trivial effect clears any significance threshold — which is exactly why the p-value is the wrong number to read here.</a:t>
-            </a:r>
+              <a:t>The Santa coefficient is $0.42 (SE $0.011, p &lt; 0.001). With 2.6 million observations even a trivial effect clears any significance threshold</a:t>
+            </a:r>
+            <a:r>
+              <a:rPr lang="en-US" sz="4400" b="0" i="0" dirty="0">
+                <a:solidFill>
+                  <a:srgbClr val="222222"/>
+                </a:solidFill>
+                <a:latin typeface="Calibri"/>
+              </a:rPr>
+              <a:t>.</a:t>
+            </a:r>
+            <a:endParaRPr sz="4400" b="0" i="0" dirty="0">
+              <a:solidFill>
+                <a:srgbClr val="222222"/>
+              </a:solidFill>
+              <a:latin typeface="Calibri"/>
+            </a:endParaRPr>
           </a:p>
         </p:txBody>
       </p:sp>
@@ -4060,7 +4670,7 @@
         <p:spPr>
           <a:xfrm>
             <a:off x="32918400" y="8595360"/>
-            <a:ext cx="9601200" cy="822960"/>
+            <a:ext cx="9601200" cy="846386"/>
           </a:xfrm>
           <a:prstGeom prst="rect">
             <a:avLst/>
@@ -4068,7 +4678,7 @@
           <a:noFill/>
         </p:spPr>
         <p:txBody>
-          <a:bodyPr wrap="square" lIns="0" rIns="0" tIns="0" bIns="0" anchor="t">
+          <a:bodyPr wrap="square" lIns="0" tIns="0" rIns="0" bIns="0" anchor="t">
             <a:spAutoFit/>
           </a:bodyPr>
           <a:lstStyle/>
@@ -4079,7 +4689,7 @@
               </a:spcAft>
             </a:pPr>
             <a:r>
-              <a:rPr sz="4000" b="1" i="0">
+              <a:rPr sz="5500" b="1" i="0">
                 <a:solidFill>
                   <a:srgbClr val="0F5FA6"/>
                 </a:solidFill>
@@ -4099,7 +4709,7 @@
         <p:spPr>
           <a:xfrm>
             <a:off x="32918400" y="9692640"/>
-            <a:ext cx="9601200" cy="4572000"/>
+            <a:ext cx="9601200" cy="2462213"/>
           </a:xfrm>
           <a:prstGeom prst="rect">
             <a:avLst/>
@@ -4107,7 +4717,7 @@
           <a:noFill/>
         </p:spPr>
         <p:txBody>
-          <a:bodyPr wrap="square" lIns="0" rIns="0" tIns="0" bIns="0" anchor="t">
+          <a:bodyPr wrap="square" lIns="0" tIns="0" rIns="0" bIns="0" anchor="t">
             <a:spAutoFit/>
           </a:bodyPr>
           <a:lstStyle/>
@@ -4118,13 +4728,67 @@
               </a:spcAft>
             </a:pPr>
             <a:r>
-              <a:rPr sz="2600" b="0" i="0">
+              <a:rPr sz="4000" b="0" i="0" dirty="0">
                 <a:solidFill>
                   <a:srgbClr val="222222"/>
                 </a:solidFill>
                 <a:latin typeface="Calibri"/>
               </a:rPr>
-              <a:t>Santa's gifts are priced exactly like the ones parents buy, which is what we would expect if parents were buying them. The Grinch hypothesis survives.</a:t>
+              <a:t>Santa's gifts are priced like the ones parents buy</a:t>
+            </a:r>
+            <a:r>
+              <a:rPr lang="en-US" sz="4000" b="0" i="0" dirty="0">
+                <a:solidFill>
+                  <a:srgbClr val="222222"/>
+                </a:solidFill>
+                <a:latin typeface="Calibri"/>
+              </a:rPr>
+              <a:t>. This is the expected outcome if </a:t>
+            </a:r>
+            <a:r>
+              <a:rPr sz="4000" b="0" i="0" dirty="0">
+                <a:solidFill>
+                  <a:srgbClr val="222222"/>
+                </a:solidFill>
+                <a:latin typeface="Calibri"/>
+              </a:rPr>
+              <a:t>parents </a:t>
+            </a:r>
+            <a:r>
+              <a:rPr lang="en-US" sz="4000" b="0" i="0" dirty="0">
+                <a:solidFill>
+                  <a:srgbClr val="222222"/>
+                </a:solidFill>
+                <a:latin typeface="Calibri"/>
+              </a:rPr>
+              <a:t>made most purchases</a:t>
+            </a:r>
+            <a:r>
+              <a:rPr sz="4000" b="0" i="0" dirty="0">
+                <a:solidFill>
+                  <a:srgbClr val="222222"/>
+                </a:solidFill>
+                <a:latin typeface="Calibri"/>
+              </a:rPr>
+              <a:t>. </a:t>
+            </a:r>
+            <a:r>
+              <a:rPr lang="en-US" sz="4000" b="0" i="0" dirty="0">
+                <a:solidFill>
+                  <a:srgbClr val="222222"/>
+                </a:solidFill>
+                <a:latin typeface="Calibri"/>
+              </a:rPr>
+              <a:t>Our </a:t>
+            </a:r>
+            <a:r>
+              <a:rPr sz="4000" b="0" i="0" dirty="0">
+                <a:solidFill>
+                  <a:srgbClr val="222222"/>
+                </a:solidFill>
+                <a:latin typeface="Calibri"/>
+              </a:rPr>
+              <a:t>Grinch hypothesis survives.</a:t>
             </a:r>
           </a:p>
         </p:txBody>
@@ -4138,7 +4802,7 @@
         <p:spPr>
           <a:xfrm>
             <a:off x="32918400" y="15179040"/>
-            <a:ext cx="9601200" cy="822960"/>
+            <a:ext cx="9601200" cy="846386"/>
           </a:xfrm>
           <a:prstGeom prst="rect">
             <a:avLst/>
@@ -4146,7 +4810,7 @@
           <a:noFill/>
         </p:spPr>
         <p:txBody>
-          <a:bodyPr wrap="square" lIns="0" rIns="0" tIns="0" bIns="0" anchor="t">
+          <a:bodyPr wrap="square" lIns="0" tIns="0" rIns="0" bIns="0" anchor="t">
             <a:spAutoFit/>
           </a:bodyPr>
           <a:lstStyle/>
@@ -4157,7 +4821,7 @@
               </a:spcAft>
             </a:pPr>
             <a:r>
-              <a:rPr sz="4000" b="1" i="0">
+              <a:rPr sz="5500" b="1" i="0">
                 <a:solidFill>
                   <a:srgbClr val="0F5FA6"/>
                 </a:solidFill>
@@ -4177,7 +4841,7 @@
         <p:spPr>
           <a:xfrm>
             <a:off x="32918400" y="16276320"/>
-            <a:ext cx="9601200" cy="5943600"/>
+            <a:ext cx="9601200" cy="2462213"/>
           </a:xfrm>
           <a:prstGeom prst="rect">
             <a:avLst/>
@@ -4185,7 +4849,7 @@
           <a:noFill/>
         </p:spPr>
         <p:txBody>
-          <a:bodyPr wrap="square" lIns="0" rIns="0" tIns="0" bIns="0" anchor="t">
+          <a:bodyPr wrap="square" lIns="0" tIns="0" rIns="0" bIns="0" anchor="t">
             <a:spAutoFit/>
           </a:bodyPr>
           <a:lstStyle/>
@@ -4196,7 +4860,7 @@
               </a:spcAft>
             </a:pPr>
             <a:r>
-              <a:rPr sz="2600" b="0" i="0">
+              <a:rPr sz="4000" b="0" i="0" dirty="0">
                 <a:solidFill>
                   <a:srgbClr val="222222"/>
                 </a:solidFill>
@@ -4216,7 +4880,7 @@
         <p:spPr>
           <a:xfrm>
             <a:off x="32918400" y="22494240"/>
-            <a:ext cx="9601200" cy="822960"/>
+            <a:ext cx="9601200" cy="846386"/>
           </a:xfrm>
           <a:prstGeom prst="rect">
             <a:avLst/>
@@ -4224,7 +4888,7 @@
           <a:noFill/>
         </p:spPr>
         <p:txBody>
-          <a:bodyPr wrap="square" lIns="0" rIns="0" tIns="0" bIns="0" anchor="t">
+          <a:bodyPr wrap="square" lIns="0" tIns="0" rIns="0" bIns="0" anchor="t">
             <a:spAutoFit/>
           </a:bodyPr>
           <a:lstStyle/>
@@ -4235,7 +4899,7 @@
               </a:spcAft>
             </a:pPr>
             <a:r>
-              <a:rPr sz="4000" b="1" i="0">
+              <a:rPr sz="5500" b="1" i="0">
                 <a:solidFill>
                   <a:srgbClr val="0F5FA6"/>
                 </a:solidFill>
@@ -4255,7 +4919,7 @@
         <p:spPr>
           <a:xfrm>
             <a:off x="32918400" y="23591520"/>
-            <a:ext cx="9601200" cy="3657600"/>
+            <a:ext cx="9601200" cy="3898503"/>
           </a:xfrm>
           <a:prstGeom prst="rect">
             <a:avLst/>
@@ -4263,7 +4927,7 @@
           <a:noFill/>
         </p:spPr>
         <p:txBody>
-          <a:bodyPr wrap="square" lIns="0" rIns="0" tIns="0" bIns="0" anchor="t">
+          <a:bodyPr wrap="square" lIns="0" tIns="0" rIns="0" bIns="0" anchor="t">
             <a:spAutoFit/>
           </a:bodyPr>
           <a:lstStyle/>
@@ -4274,7 +4938,7 @@
               </a:spcAft>
             </a:pPr>
             <a:r>
-              <a:rPr sz="1800" b="0" i="0">
+              <a:rPr sz="4000" b="0" i="0">
                 <a:solidFill>
                   <a:srgbClr val="666666"/>
                 </a:solidFill>
@@ -4290,7 +4954,7 @@
               </a:spcAft>
             </a:pPr>
             <a:r>
-              <a:rPr sz="1800" b="0" i="0">
+              <a:rPr sz="4000" b="0" i="0">
                 <a:solidFill>
                   <a:srgbClr val="666666"/>
                 </a:solidFill>
@@ -4306,7 +4970,7 @@
               </a:spcAft>
             </a:pPr>
             <a:r>
-              <a:rPr sz="1800" b="0" i="0">
+              <a:rPr sz="4000" b="0" i="0">
                 <a:solidFill>
                   <a:srgbClr val="666666"/>
                 </a:solidFill>
@@ -4326,7 +4990,7 @@
           <p:nvPr/>
         </p:nvPicPr>
         <p:blipFill>
-          <a:blip r:embed="rId3"/>
+          <a:blip r:embed="rId4"/>
           <a:stretch>
             <a:fillRect/>
           </a:stretch>
@@ -4358,7 +5022,7 @@
           <a:noFill/>
         </p:spPr>
         <p:txBody>
-          <a:bodyPr wrap="square" lIns="0" rIns="0" tIns="0" bIns="0" anchor="t">
+          <a:bodyPr wrap="square" lIns="0" tIns="0" rIns="0" bIns="0" anchor="t">
             <a:spAutoFit/>
           </a:bodyPr>
           <a:lstStyle/>
@@ -4706,4 +5370,319 @@
   </a:objectDefaults>
   <a:extraClrSchemeLst/>
 </a:theme>
+</file>
+
+<file path=ppt/theme/theme2.xml><?xml version="1.0" encoding="utf-8"?>
+<a:theme xmlns:a="http://schemas.openxmlformats.org/drawingml/2006/main" name="Office Theme">
+  <a:themeElements>
+    <a:clrScheme name="Office">
+      <a:dk1>
+        <a:sysClr val="windowText" lastClr="000000"/>
+      </a:dk1>
+      <a:lt1>
+        <a:sysClr val="window" lastClr="FFFFFF"/>
+      </a:lt1>
+      <a:dk2>
+        <a:srgbClr val="0E2841"/>
+      </a:dk2>
+      <a:lt2>
+        <a:srgbClr val="E8E8E8"/>
+      </a:lt2>
+      <a:accent1>
+        <a:srgbClr val="156082"/>
+      </a:accent1>
+      <a:accent2>
+        <a:srgbClr val="E97132"/>
+      </a:accent2>
+      <a:accent3>
+        <a:srgbClr val="196B24"/>
+      </a:accent3>
+      <a:accent4>
+        <a:srgbClr val="0F9ED5"/>
+      </a:accent4>
+      <a:accent5>
+        <a:srgbClr val="A02B93"/>
+      </a:accent5>
+      <a:accent6>
+        <a:srgbClr val="4EA72E"/>
+      </a:accent6>
+      <a:hlink>
+        <a:srgbClr val="467886"/>
+      </a:hlink>
+      <a:folHlink>
+        <a:srgbClr val="96607D"/>
+      </a:folHlink>
+    </a:clrScheme>
+    <a:fontScheme name="Office">
+      <a:majorFont>
+        <a:latin typeface="Aptos Display" panose="02110004020202020204"/>
+        <a:ea typeface=""/>
+        <a:cs typeface=""/>
+        <a:font script="Jpan" typeface="游ゴシック Light"/>
+        <a:font script="Hang" typeface="맑은 고딕"/>
+        <a:font script="Hans" typeface="等线 Light"/>
+        <a:font script="Hant" typeface="新細明體"/>
+        <a:font script="Arab" typeface="Times New Roman"/>
+        <a:font script="Hebr" typeface="Times New Roman"/>
+        <a:font script="Thai" typeface="Angsana New"/>
+        <a:font script="Ethi" typeface="Nyala"/>
+        <a:font script="Beng" typeface="Vrinda"/>
+        <a:font script="Gujr" typeface="Shruti"/>
+        <a:font script="Khmr" typeface="MoolBoran"/>
+        <a:font script="Knda" typeface="Tunga"/>
+        <a:font script="Guru" typeface="Raavi"/>
+        <a:font script="Cans" typeface="Euphemia"/>
+        <a:font script="Cher" typeface="Plantagenet Cherokee"/>
+        <a:font script="Yiii" typeface="Microsoft Yi Baiti"/>
+        <a:font script="Tibt" typeface="Microsoft Himalaya"/>
+        <a:font script="Thaa" typeface="MV Boli"/>
+        <a:font script="Deva" typeface="Mangal"/>
+        <a:font script="Telu" typeface="Gautami"/>
+        <a:font script="Taml" typeface="Latha"/>
+        <a:font script="Syrc" typeface="Estrangelo Edessa"/>
+        <a:font script="Orya" typeface="Kalinga"/>
+        <a:font script="Mlym" typeface="Kartika"/>
+        <a:font script="Laoo" typeface="DokChampa"/>
+        <a:font script="Sinh" typeface="Iskoola Pota"/>
+        <a:font script="Mong" typeface="Mongolian Baiti"/>
+        <a:font script="Viet" typeface="Times New Roman"/>
+        <a:font script="Uigh" typeface="Microsoft Uighur"/>
+        <a:font script="Geor" typeface="Sylfaen"/>
+        <a:font script="Armn" typeface="Arial"/>
+        <a:font script="Bugi" typeface="Leelawadee UI"/>
+        <a:font script="Bopo" typeface="Microsoft JhengHei"/>
+        <a:font script="Java" typeface="Javanese Text"/>
+        <a:font script="Lisu" typeface="Segoe UI"/>
+        <a:font script="Mymr" typeface="Myanmar Text"/>
+        <a:font script="Nkoo" typeface="Ebrima"/>
+        <a:font script="Olck" typeface="Nirmala UI"/>
+        <a:font script="Osma" typeface="Ebrima"/>
+        <a:font script="Phag" typeface="Phagspa"/>
+        <a:font script="Syrn" typeface="Estrangelo Edessa"/>
+        <a:font script="Syrj" typeface="Estrangelo Edessa"/>
+        <a:font script="Syre" typeface="Estrangelo Edessa"/>
+        <a:font script="Sora" typeface="Nirmala UI"/>
+        <a:font script="Tale" typeface="Microsoft Tai Le"/>
+        <a:font script="Talu" typeface="Microsoft New Tai Lue"/>
+        <a:font script="Tfng" typeface="Ebrima"/>
+      </a:majorFont>
+      <a:minorFont>
+        <a:latin typeface="Aptos" panose="02110004020202020204"/>
+        <a:ea typeface=""/>
+        <a:cs typeface=""/>
+        <a:font script="Jpan" typeface="游ゴシック"/>
+        <a:font script="Hang" typeface="맑은 고딕"/>
+        <a:font script="Hans" typeface="等线"/>
+        <a:font script="Hant" typeface="新細明體"/>
+        <a:font script="Arab" typeface="Arial"/>
+        <a:font script="Hebr" typeface="Arial"/>
+        <a:font script="Thai" typeface="Cordia New"/>
+        <a:font script="Ethi" typeface="Nyala"/>
+        <a:font script="Beng" typeface="Vrinda"/>
+        <a:font script="Gujr" typeface="Shruti"/>
+        <a:font script="Khmr" typeface="DaunPenh"/>
+        <a:font script="Knda" typeface="Tunga"/>
+        <a:font script="Guru" typeface="Raavi"/>
+        <a:font script="Cans" typeface="Euphemia"/>
+        <a:font script="Cher" typeface="Plantagenet Cherokee"/>
+        <a:font script="Yiii" typeface="Microsoft Yi Baiti"/>
+        <a:font script="Tibt" typeface="Microsoft Himalaya"/>
+        <a:font script="Thaa" typeface="MV Boli"/>
+        <a:font script="Deva" typeface="Mangal"/>
+        <a:font script="Telu" typeface="Gautami"/>
+        <a:font script="Taml" typeface="Latha"/>
+        <a:font script="Syrc" typeface="Estrangelo Edessa"/>
+        <a:font script="Orya" typeface="Kalinga"/>
+        <a:font script="Mlym" typeface="Kartika"/>
+        <a:font script="Laoo" typeface="DokChampa"/>
+        <a:font script="Sinh" typeface="Iskoola Pota"/>
+        <a:font script="Mong" typeface="Mongolian Baiti"/>
+        <a:font script="Viet" typeface="Arial"/>
+        <a:font script="Uigh" typeface="Microsoft Uighur"/>
+        <a:font script="Geor" typeface="Sylfaen"/>
+        <a:font script="Armn" typeface="Arial"/>
+        <a:font script="Bugi" typeface="Leelawadee UI"/>
+        <a:font script="Bopo" typeface="Microsoft JhengHei"/>
+        <a:font script="Java" typeface="Javanese Text"/>
+        <a:font script="Lisu" typeface="Segoe UI"/>
+        <a:font script="Mymr" typeface="Myanmar Text"/>
+        <a:font script="Nkoo" typeface="Ebrima"/>
+        <a:font script="Olck" typeface="Nirmala UI"/>
+        <a:font script="Osma" typeface="Ebrima"/>
+        <a:font script="Phag" typeface="Phagspa"/>
+        <a:font script="Syrn" typeface="Estrangelo Edessa"/>
+        <a:font script="Syrj" typeface="Estrangelo Edessa"/>
+        <a:font script="Syre" typeface="Estrangelo Edessa"/>
+        <a:font script="Sora" typeface="Nirmala UI"/>
+        <a:font script="Tale" typeface="Microsoft Tai Le"/>
+        <a:font script="Talu" typeface="Microsoft New Tai Lue"/>
+        <a:font script="Tfng" typeface="Ebrima"/>
+      </a:minorFont>
+    </a:fontScheme>
+    <a:fmtScheme name="Office">
+      <a:fillStyleLst>
+        <a:solidFill>
+          <a:schemeClr val="phClr"/>
+        </a:solidFill>
+        <a:gradFill rotWithShape="1">
+          <a:gsLst>
+            <a:gs pos="0">
+              <a:schemeClr val="phClr">
+                <a:lumMod val="110000"/>
+                <a:satMod val="105000"/>
+                <a:tint val="67000"/>
+              </a:schemeClr>
+            </a:gs>
+            <a:gs pos="50000">
+              <a:schemeClr val="phClr">
+                <a:lumMod val="105000"/>
+                <a:satMod val="103000"/>
+                <a:tint val="73000"/>
+              </a:schemeClr>
+            </a:gs>
+            <a:gs pos="100000">
+              <a:schemeClr val="phClr">
+                <a:lumMod val="105000"/>
+                <a:satMod val="109000"/>
+                <a:tint val="81000"/>
+              </a:schemeClr>
+            </a:gs>
+          </a:gsLst>
+          <a:lin ang="5400000" scaled="0"/>
+        </a:gradFill>
+        <a:gradFill rotWithShape="1">
+          <a:gsLst>
+            <a:gs pos="0">
+              <a:schemeClr val="phClr">
+                <a:satMod val="103000"/>
+                <a:lumMod val="102000"/>
+                <a:tint val="94000"/>
+              </a:schemeClr>
+            </a:gs>
+            <a:gs pos="50000">
+              <a:schemeClr val="phClr">
+                <a:satMod val="110000"/>
+                <a:lumMod val="100000"/>
+                <a:shade val="100000"/>
+              </a:schemeClr>
+            </a:gs>
+            <a:gs pos="100000">
+              <a:schemeClr val="phClr">
+                <a:lumMod val="99000"/>
+                <a:satMod val="120000"/>
+                <a:shade val="78000"/>
+              </a:schemeClr>
+            </a:gs>
+          </a:gsLst>
+          <a:lin ang="5400000" scaled="0"/>
+        </a:gradFill>
+      </a:fillStyleLst>
+      <a:lnStyleLst>
+        <a:ln w="12700" cap="flat" cmpd="sng" algn="ctr">
+          <a:solidFill>
+            <a:schemeClr val="phClr"/>
+          </a:solidFill>
+          <a:prstDash val="solid"/>
+          <a:miter lim="800000"/>
+        </a:ln>
+        <a:ln w="19050" cap="flat" cmpd="sng" algn="ctr">
+          <a:solidFill>
+            <a:schemeClr val="phClr"/>
+          </a:solidFill>
+          <a:prstDash val="solid"/>
+          <a:miter lim="800000"/>
+        </a:ln>
+        <a:ln w="25400" cap="flat" cmpd="sng" algn="ctr">
+          <a:solidFill>
+            <a:schemeClr val="phClr"/>
+          </a:solidFill>
+          <a:prstDash val="solid"/>
+          <a:miter lim="800000"/>
+        </a:ln>
+      </a:lnStyleLst>
+      <a:effectStyleLst>
+        <a:effectStyle>
+          <a:effectLst/>
+        </a:effectStyle>
+        <a:effectStyle>
+          <a:effectLst/>
+        </a:effectStyle>
+        <a:effectStyle>
+          <a:effectLst>
+            <a:outerShdw blurRad="57150" dist="19050" dir="5400000" algn="ctr" rotWithShape="0">
+              <a:srgbClr val="000000">
+                <a:alpha val="63000"/>
+              </a:srgbClr>
+            </a:outerShdw>
+          </a:effectLst>
+        </a:effectStyle>
+      </a:effectStyleLst>
+      <a:bgFillStyleLst>
+        <a:solidFill>
+          <a:schemeClr val="phClr"/>
+        </a:solidFill>
+        <a:solidFill>
+          <a:schemeClr val="phClr">
+            <a:tint val="95000"/>
+            <a:satMod val="170000"/>
+          </a:schemeClr>
+        </a:solidFill>
+        <a:gradFill rotWithShape="1">
+          <a:gsLst>
+            <a:gs pos="0">
+              <a:schemeClr val="phClr">
+                <a:tint val="93000"/>
+                <a:satMod val="150000"/>
+                <a:shade val="98000"/>
+                <a:lumMod val="102000"/>
+              </a:schemeClr>
+            </a:gs>
+            <a:gs pos="50000">
+              <a:schemeClr val="phClr">
+                <a:tint val="98000"/>
+                <a:satMod val="130000"/>
+                <a:shade val="90000"/>
+                <a:lumMod val="103000"/>
+              </a:schemeClr>
+            </a:gs>
+            <a:gs pos="100000">
+              <a:schemeClr val="phClr">
+                <a:shade val="63000"/>
+                <a:satMod val="120000"/>
+              </a:schemeClr>
+            </a:gs>
+          </a:gsLst>
+          <a:lin ang="5400000" scaled="0"/>
+        </a:gradFill>
+      </a:bgFillStyleLst>
+    </a:fmtScheme>
+  </a:themeElements>
+  <a:objectDefaults>
+    <a:lnDef>
+      <a:spPr/>
+      <a:bodyPr/>
+      <a:lstStyle/>
+      <a:style>
+        <a:lnRef idx="2">
+          <a:schemeClr val="accent1"/>
+        </a:lnRef>
+        <a:fillRef idx="0">
+          <a:schemeClr val="accent1"/>
+        </a:fillRef>
+        <a:effectRef idx="1">
+          <a:schemeClr val="accent1"/>
+        </a:effectRef>
+        <a:fontRef idx="minor">
+          <a:schemeClr val="tx1"/>
+        </a:fontRef>
+      </a:style>
+    </a:lnDef>
+  </a:objectDefaults>
+  <a:extraClrSchemeLst/>
+  <a:extLst>
+    <a:ext uri="{05A4C25C-085E-4340-85A3-A5531E510DB2}">
+      <thm15:themeFamily xmlns:thm15="http://schemas.microsoft.com/office/thememl/2012/main" name="Office Theme" id="{2E142A2C-CD16-42D6-873A-C26D2A0506FA}" vid="{1BDDFF52-6CD6-40A5-AB3C-68EB2F1E4D0A}"/>
+    </a:ext>
+  </a:extLst>
+</a:theme>
 </file>
</xml_diff>